<commit_message>
Ajout des captures visuelles (images terminal) dans les slides
- Générateur render_terminal.py (PNG style terminal, colorisé)
- Images: canary en cours, rollback automatique, logs de sonde
- Slides démo 1 & 2 enrichies des sorties réelles du cluster
</commit_message>
<xml_diff>
--- a/slides/argo-rollouts.pptx
+++ b/slides/argo-rollouts.pptx
@@ -3674,98 +3674,7 @@
                   <a:srgbClr val="EF7627"/>
                 </a:solidFill>
               </a:rPr>
-              <a:t>set image … :green  →  le rollout progresse :</a:t>
-            </a:r>
-          </a:p>
-          <a:p>
-            <a:pPr>
-              <a:spcBef>
-                <a:spcPts val="200"/>
-              </a:spcBef>
-              <a:spcAft>
-                <a:spcPts val="200"/>
-              </a:spcAft>
-            </a:pPr>
-            <a:r>
-              <a:rPr sz="1500">
-                <a:solidFill>
-                  <a:srgbClr val="555A66"/>
-                </a:solidFill>
-                <a:latin typeface="Consolas"/>
-              </a:rPr>
-              <a:t>Step 1/9  setWeight 20%   ▸ 1 pod green / 4 pods blue</a:t>
-            </a:r>
-          </a:p>
-          <a:p>
-            <a:pPr>
-              <a:spcBef>
-                <a:spcPts val="200"/>
-              </a:spcBef>
-              <a:spcAft>
-                <a:spcPts val="200"/>
-              </a:spcAft>
-            </a:pPr>
-            <a:r>
-              <a:rPr sz="1500">
-                <a:solidFill>
-                  <a:srgbClr val="555A66"/>
-                </a:solidFill>
-                <a:latin typeface="Consolas"/>
-              </a:rPr>
-              <a:t>Step 4/9  setWeight 40%   ▸ AnalysisRun lancé</a:t>
-            </a:r>
-          </a:p>
-          <a:p>
-            <a:pPr>
-              <a:spcBef>
-                <a:spcPts val="200"/>
-              </a:spcBef>
-              <a:spcAft>
-                <a:spcPts val="200"/>
-              </a:spcAft>
-            </a:pPr>
-            <a:r>
-              <a:rPr sz="1500">
-                <a:solidFill>
-                  <a:srgbClr val="555A66"/>
-                </a:solidFill>
-                <a:latin typeface="Consolas"/>
-              </a:rPr>
-              <a:t>   probe ▸ "30/30 requetes en succes -&gt; 100% (seuil 95%)  ANALYSE OK"</a:t>
-            </a:r>
-          </a:p>
-          <a:p>
-            <a:pPr>
-              <a:spcBef>
-                <a:spcPts val="200"/>
-              </a:spcBef>
-              <a:spcAft>
-                <a:spcPts val="200"/>
-              </a:spcAft>
-            </a:pPr>
-            <a:r>
-              <a:rPr sz="1500">
-                <a:solidFill>
-                  <a:srgbClr val="555A66"/>
-                </a:solidFill>
-                <a:latin typeface="Consolas"/>
-              </a:rPr>
-              <a:t>Step 9/9  setWeight 100%  ▸ Healthy, stable = green</a:t>
-            </a:r>
-          </a:p>
-          <a:p>
-            <a:pPr>
-              <a:spcAft>
-                <a:spcPts val="400"/>
-              </a:spcAft>
-            </a:pPr>
-            <a:r>
-              <a:rPr sz="1800" b="0">
-                <a:solidFill>
-                  <a:srgbClr val="1B1F2A"/>
-                </a:solidFill>
-              </a:rPr>
-              <a:t/>
+              <a:t>nouvelle version → canary 20%→40% ; l'AnalysisRun sonde le canary :</a:t>
             </a:r>
           </a:p>
           <a:p>
@@ -3776,11 +3685,35 @@
                   <a:srgbClr val="2EA043"/>
                 </a:solidFill>
               </a:rPr>
-              <a:t>Analyse réussie → promotion automatique jusqu'à 100%.</a:t>
-            </a:r>
-          </a:p>
-        </p:txBody>
-      </p:sp>
+              <a:t>"30/30 requetes en succes -&gt; 100% (seuil 95%)" → promotion automatique 100%</a:t>
+            </a:r>
+          </a:p>
+        </p:txBody>
+      </p:sp>
+      <p:pic>
+        <p:nvPicPr>
+          <p:cNvPr id="6" name="Picture 5" descr="demo-canary-inprogress.png"/>
+          <p:cNvPicPr>
+            <a:picLocks noChangeAspect="1"/>
+          </p:cNvPicPr>
+          <p:nvPr/>
+        </p:nvPicPr>
+        <p:blipFill>
+          <a:blip r:embed="rId2"/>
+          <a:stretch>
+            <a:fillRect/>
+          </a:stretch>
+        </p:blipFill>
+        <p:spPr>
+          <a:xfrm>
+            <a:off x="2587003" y="2103120"/>
+            <a:ext cx="7017688" cy="4480560"/>
+          </a:xfrm>
+          <a:prstGeom prst="rect">
+            <a:avLst/>
+          </a:prstGeom>
+        </p:spPr>
+      </p:pic>
     </p:spTree>
   </p:cSld>
   <p:clrMapOvr>
@@ -3953,117 +3886,7 @@
                   <a:srgbClr val="EF7627"/>
                 </a:solidFill>
               </a:rPr>
-              <a:t>set image … :bad-red  →  l'analyse sonde le canary :</a:t>
-            </a:r>
-          </a:p>
-          <a:p>
-            <a:pPr>
-              <a:spcBef>
-                <a:spcPts val="200"/>
-              </a:spcBef>
-              <a:spcAft>
-                <a:spcPts val="200"/>
-              </a:spcAft>
-            </a:pPr>
-            <a:r>
-              <a:rPr sz="1500">
-                <a:solidFill>
-                  <a:srgbClr val="555A66"/>
-                </a:solidFill>
-                <a:latin typeface="Consolas"/>
-              </a:rPr>
-              <a:t>probe ▸ HTTP/1.1 500 Internal Server Error  (x25)</a:t>
-            </a:r>
-          </a:p>
-          <a:p>
-            <a:pPr>
-              <a:spcBef>
-                <a:spcPts val="200"/>
-              </a:spcBef>
-              <a:spcAft>
-                <a:spcPts val="200"/>
-              </a:spcAft>
-            </a:pPr>
-            <a:r>
-              <a:rPr sz="1500">
-                <a:solidFill>
-                  <a:srgbClr val="555A66"/>
-                </a:solidFill>
-                <a:latin typeface="Consolas"/>
-              </a:rPr>
-              <a:t>probe ▸ "5/30 requetes en succes -&gt; 16% (seuil 95%)  ANALYSE KO"</a:t>
-            </a:r>
-          </a:p>
-          <a:p>
-            <a:pPr>
-              <a:spcBef>
-                <a:spcPts val="200"/>
-              </a:spcBef>
-              <a:spcAft>
-                <a:spcPts val="200"/>
-              </a:spcAft>
-            </a:pPr>
-            <a:r>
-              <a:rPr sz="1500">
-                <a:solidFill>
-                  <a:srgbClr val="555A66"/>
-                </a:solidFill>
-                <a:latin typeface="Consolas"/>
-              </a:rPr>
-              <a:t>Status: Degraded</a:t>
-            </a:r>
-          </a:p>
-          <a:p>
-            <a:pPr>
-              <a:spcBef>
-                <a:spcPts val="200"/>
-              </a:spcBef>
-              <a:spcAft>
-                <a:spcPts val="200"/>
-              </a:spcAft>
-            </a:pPr>
-            <a:r>
-              <a:rPr sz="1500">
-                <a:solidFill>
-                  <a:srgbClr val="555A66"/>
-                </a:solidFill>
-                <a:latin typeface="Consolas"/>
-              </a:rPr>
-              <a:t>Message: RolloutAborted: Metric "http-success-rate" assessed Failed</a:t>
-            </a:r>
-          </a:p>
-          <a:p>
-            <a:pPr>
-              <a:spcBef>
-                <a:spcPts val="200"/>
-              </a:spcBef>
-              <a:spcAft>
-                <a:spcPts val="200"/>
-              </a:spcAft>
-            </a:pPr>
-            <a:r>
-              <a:rPr sz="1500">
-                <a:solidFill>
-                  <a:srgbClr val="555A66"/>
-                </a:solidFill>
-                <a:latin typeface="Consolas"/>
-              </a:rPr>
-              <a:t>         due to failed (1) &gt; failureLimit (0)</a:t>
-            </a:r>
-          </a:p>
-          <a:p>
-            <a:pPr>
-              <a:spcAft>
-                <a:spcPts val="400"/>
-              </a:spcAft>
-            </a:pPr>
-            <a:r>
-              <a:rPr sz="1800" b="0">
-                <a:solidFill>
-                  <a:srgbClr val="1B1F2A"/>
-                </a:solidFill>
-              </a:rPr>
-              <a:t/>
+              <a:t>bad-red → HTTP 500 ; sonde 5/30 = 16% → ANALYSE KO</a:t>
             </a:r>
           </a:p>
           <a:p>
@@ -4074,22 +3897,35 @@
                   <a:srgbClr val="C0392B"/>
                 </a:solidFill>
               </a:rPr>
-              <a:t>Analyse échouée → rollback automatique : trafic gardé sur green,</a:t>
-            </a:r>
-          </a:p>
-          <a:p>
-            <a:pPr/>
-            <a:r>
-              <a:rPr sz="1800" b="1">
-                <a:solidFill>
-                  <a:srgbClr val="C0392B"/>
-                </a:solidFill>
-              </a:rPr>
-              <a:t>zéro impact utilisateur, zéro intervention humaine.</a:t>
-            </a:r>
-          </a:p>
-        </p:txBody>
-      </p:sp>
+              <a:t>Metric Failed → RolloutAborted → trafic gardé sur green, 0 downtime</a:t>
+            </a:r>
+          </a:p>
+        </p:txBody>
+      </p:sp>
+      <p:pic>
+        <p:nvPicPr>
+          <p:cNvPr id="6" name="Picture 5" descr="demo-rollback.png"/>
+          <p:cNvPicPr>
+            <a:picLocks noChangeAspect="1"/>
+          </p:cNvPicPr>
+          <p:nvPr/>
+        </p:nvPicPr>
+        <p:blipFill>
+          <a:blip r:embed="rId2"/>
+          <a:stretch>
+            <a:fillRect/>
+          </a:stretch>
+        </p:blipFill>
+        <p:spPr>
+          <a:xfrm>
+            <a:off x="2498126" y="2468880"/>
+            <a:ext cx="7195441" cy="4023360"/>
+          </a:xfrm>
+          <a:prstGeom prst="rect">
+            <a:avLst/>
+          </a:prstGeom>
+        </p:spPr>
+      </p:pic>
     </p:spTree>
   </p:cSld>
   <p:clrMapOvr>

</xml_diff>

<commit_message>
Captures navigateur réelles (Playwright + Chromium système)
- Grille colorée multi-versions via NodePort (split de trafic visible)
- Dashboard Argo Rollouts capturé pendant un canary (weight 40)
- Nouvelle slide 'Pilotage & observabilité' (14 slides au total)
</commit_message>
<xml_diff>
--- a/slides/argo-rollouts.pptx
+++ b/slides/argo-rollouts.pptx
@@ -18,6 +18,7 @@
     <p:sldId id="266" r:id="rId17"/>
     <p:sldId id="267" r:id="rId18"/>
     <p:sldId id="268" r:id="rId19"/>
+    <p:sldId id="269" r:id="rId20"/>
   </p:sldIdLst>
   <p:sldSz cx="12191695" cy="6858000" type="screen4x3"/>
   <p:notesSz cx="6858000" cy="9144000"/>
@@ -4841,7 +4842,7 @@
                 </a:solidFill>
                 <a:latin typeface="Calibri"/>
               </a:rPr>
-              <a:t>CONCLUSION</a:t>
+              <a:t>LE DASHBOARD ARGO ROLLOUTS</a:t>
             </a:r>
           </a:p>
           <a:p>
@@ -4860,7 +4861,7 @@
                 </a:solidFill>
                 <a:latin typeface="Calibri"/>
               </a:rPr>
-              <a:t>Bilan, avis &amp; améliorations</a:t>
+              <a:t>Pilotage &amp; observabilité</a:t>
             </a:r>
           </a:p>
         </p:txBody>
@@ -5002,7 +5003,7 @@
         <p:spPr>
           <a:xfrm>
             <a:off x="777240" y="1600200"/>
-            <a:ext cx="5257800" cy="2697480"/>
+            <a:ext cx="3246120" cy="4206240"/>
           </a:xfrm>
           <a:prstGeom prst="roundRect">
             <a:avLst>
@@ -5094,7 +5095,7 @@
         <p:spPr>
           <a:xfrm>
             <a:off x="1051560" y="1783080"/>
-            <a:ext cx="4800600" cy="411480"/>
+            <a:ext cx="2788920" cy="411480"/>
           </a:xfrm>
           <a:prstGeom prst="rect">
             <a:avLst/>
@@ -5122,7 +5123,7 @@
                 </a:solidFill>
                 <a:latin typeface="Calibri"/>
               </a:rPr>
-              <a:t>Ce que j'ai appris</a:t>
+              <a:t>Vue temps réel</a:t>
             </a:r>
           </a:p>
         </p:txBody>
@@ -5136,7 +5137,7 @@
         <p:spPr>
           <a:xfrm>
             <a:off x="1051560" y="2313432"/>
-            <a:ext cx="4754880" cy="1783080"/>
+            <a:ext cx="2743200" cy="3291839"/>
           </a:xfrm>
           <a:prstGeom prst="rect">
             <a:avLst/>
@@ -5173,7 +5174,7 @@
                 </a:solidFill>
                 <a:latin typeface="Calibri"/>
               </a:rPr>
-              <a:t>Le progressive delivery en pratique</a:t>
+              <a:t>Stratégie &amp; poids actuel (40 %)</a:t>
             </a:r>
           </a:p>
           <a:p>
@@ -5201,7 +5202,7 @@
                 </a:solidFill>
                 <a:latin typeface="Calibri"/>
               </a:rPr>
-              <a:t>L'imbrication GitOps ↔ Rollouts</a:t>
+              <a:t>Révisions stable / canary</a:t>
             </a:r>
           </a:p>
           <a:p>
@@ -5229,7 +5230,63 @@
                 </a:solidFill>
                 <a:latin typeface="Calibri"/>
               </a:rPr>
-              <a:t>Les métriques comme contrat de qualité</a:t>
+              <a:t>État des pods et analyses</a:t>
+            </a:r>
+          </a:p>
+          <a:p>
+            <a:pPr>
+              <a:spcBef>
+                <a:spcPts val="0"/>
+              </a:spcBef>
+              <a:spcAft>
+                <a:spcPts val="600"/>
+              </a:spcAft>
+            </a:pPr>
+            <a:r>
+              <a:rPr sz="1400" b="1">
+                <a:solidFill>
+                  <a:srgbClr val="EF7627"/>
+                </a:solidFill>
+                <a:latin typeface="Calibri"/>
+              </a:rPr>
+              <a:t>▸  </a:t>
+            </a:r>
+            <a:r>
+              <a:rPr sz="1400" b="0">
+                <a:solidFill>
+                  <a:srgbClr val="E8EAED"/>
+                </a:solidFill>
+                <a:latin typeface="Calibri"/>
+              </a:rPr>
+              <a:t>Pause / Promote / Restart en 1 clic</a:t>
+            </a:r>
+          </a:p>
+          <a:p>
+            <a:pPr>
+              <a:spcBef>
+                <a:spcPts val="0"/>
+              </a:spcBef>
+              <a:spcAft>
+                <a:spcPts val="600"/>
+              </a:spcAft>
+            </a:pPr>
+            <a:r>
+              <a:rPr sz="1400" b="1">
+                <a:solidFill>
+                  <a:srgbClr val="979FB0"/>
+                </a:solidFill>
+                <a:latin typeface="Calibri"/>
+              </a:rPr>
+              <a:t>▸  </a:t>
+            </a:r>
+            <a:r>
+              <a:rPr sz="1400" b="0">
+                <a:solidFill>
+                  <a:srgbClr val="979FB0"/>
+                </a:solidFill>
+                <a:latin typeface="Calibri"/>
+              </a:rPr>
+              <a:t>Capture pendant un canary figé</a:t>
             </a:r>
           </a:p>
         </p:txBody>
@@ -5242,12 +5299,12 @@
         </p:nvSpPr>
         <p:spPr>
           <a:xfrm>
-            <a:off x="6263640" y="1600200"/>
-            <a:ext cx="5120640" cy="2697480"/>
+            <a:off x="4197096" y="1545336"/>
+            <a:ext cx="5957642" cy="4407408"/>
           </a:xfrm>
           <a:prstGeom prst="roundRect">
             <a:avLst>
-              <a:gd name="adj" fmla="val 6000"/>
+              <a:gd name="adj" fmla="val 3000"/>
             </a:avLst>
           </a:prstGeom>
           <a:solidFill>
@@ -5282,16 +5339,66 @@
           </a:p>
         </p:txBody>
       </p:sp>
-      <p:sp>
-        <p:nvSpPr>
-          <p:cNvPr id="12" name="Rectangle 11"/>
+      <p:pic>
+        <p:nvPicPr>
+          <p:cNvPr id="12" name="Picture 11" descr="dashboard-canary.png"/>
+          <p:cNvPicPr>
+            <a:picLocks noChangeAspect="1"/>
+          </p:cNvPicPr>
+          <p:nvPr/>
+        </p:nvPicPr>
+        <p:blipFill>
+          <a:blip r:embed="rId2"/>
+          <a:stretch>
+            <a:fillRect/>
+          </a:stretch>
+        </p:blipFill>
+        <p:spPr>
+          <a:xfrm>
+            <a:off x="4251960" y="1600200"/>
+            <a:ext cx="5847914" cy="4297680"/>
+          </a:xfrm>
+          <a:prstGeom prst="rect">
+            <a:avLst/>
+          </a:prstGeom>
+        </p:spPr>
+      </p:pic>
+    </p:spTree>
+  </p:cSld>
+  <p:clrMapOvr>
+    <a:masterClrMapping/>
+  </p:clrMapOvr>
+</p:sld>
+</file>
+
+<file path=ppt/slides/slide13.xml><?xml version="1.0" encoding="utf-8"?>
+<p:sld xmlns:a="http://schemas.openxmlformats.org/drawingml/2006/main" xmlns:p="http://schemas.openxmlformats.org/presentationml/2006/main" xmlns:r="http://schemas.openxmlformats.org/officeDocument/2006/relationships">
+  <p:cSld>
+    <p:bg>
+      <p:bgPr>
+        <a:solidFill>
+          <a:srgbClr val="141823"/>
+        </a:solidFill>
+        <a:effectLst/>
+      </p:bgPr>
+    </p:bg>
+    <p:spTree>
+      <p:nvGrpSpPr>
+        <p:cNvPr id="1" name=""/>
+        <p:cNvGrpSpPr/>
+        <p:nvPr/>
+      </p:nvGrpSpPr>
+      <p:grpSpPr/>
+      <p:sp>
+        <p:nvSpPr>
+          <p:cNvPr id="2" name="Rectangle 1"/>
           <p:cNvSpPr/>
           <p:nvPr/>
         </p:nvSpPr>
         <p:spPr>
           <a:xfrm>
-            <a:off x="6263640" y="1764792"/>
-            <a:ext cx="91440" cy="384048"/>
+            <a:off x="502920" y="566928"/>
+            <a:ext cx="146304" cy="457200"/>
           </a:xfrm>
           <a:prstGeom prst="rect">
             <a:avLst/>
@@ -5328,14 +5435,119 @@
       </p:sp>
       <p:sp>
         <p:nvSpPr>
-          <p:cNvPr id="13" name="TextBox 12"/>
+          <p:cNvPr id="3" name="TextBox 2"/>
           <p:cNvSpPr txBox="1"/>
           <p:nvPr/>
         </p:nvSpPr>
         <p:spPr>
           <a:xfrm>
-            <a:off x="6537959" y="1783080"/>
-            <a:ext cx="4663440" cy="411480"/>
+            <a:off x="777240" y="457200"/>
+            <a:ext cx="10607040" cy="914400"/>
+          </a:xfrm>
+          <a:prstGeom prst="rect">
+            <a:avLst/>
+          </a:prstGeom>
+          <a:noFill/>
+        </p:spPr>
+        <p:txBody>
+          <a:bodyPr wrap="square" anchor="ctr" lIns="0" rIns="0" tIns="0" bIns="0">
+            <a:spAutoFit/>
+          </a:bodyPr>
+          <a:lstStyle/>
+          <a:p>
+            <a:pPr algn="l">
+              <a:spcBef>
+                <a:spcPts val="0"/>
+              </a:spcBef>
+              <a:spcAft>
+                <a:spcPts val="200"/>
+              </a:spcAft>
+            </a:pPr>
+            <a:r>
+              <a:rPr sz="1100" b="1">
+                <a:solidFill>
+                  <a:srgbClr val="EF7627"/>
+                </a:solidFill>
+                <a:latin typeface="Calibri"/>
+              </a:rPr>
+              <a:t>CONCLUSION</a:t>
+            </a:r>
+          </a:p>
+          <a:p>
+            <a:pPr algn="l">
+              <a:spcBef>
+                <a:spcPts val="0"/>
+              </a:spcBef>
+              <a:spcAft>
+                <a:spcPts val="200"/>
+              </a:spcAft>
+            </a:pPr>
+            <a:r>
+              <a:rPr sz="2700" b="1">
+                <a:solidFill>
+                  <a:srgbClr val="FFFFFF"/>
+                </a:solidFill>
+                <a:latin typeface="Calibri"/>
+              </a:rPr>
+              <a:t>Bilan, avis &amp; améliorations</a:t>
+            </a:r>
+          </a:p>
+        </p:txBody>
+      </p:sp>
+      <p:sp>
+        <p:nvSpPr>
+          <p:cNvPr id="4" name="Rectangle 3"/>
+          <p:cNvSpPr/>
+          <p:nvPr/>
+        </p:nvSpPr>
+        <p:spPr>
+          <a:xfrm>
+            <a:off x="502920" y="1325880"/>
+            <a:ext cx="11183112" cy="20116"/>
+          </a:xfrm>
+          <a:prstGeom prst="rect">
+            <a:avLst/>
+          </a:prstGeom>
+          <a:solidFill>
+            <a:srgbClr val="323C4F"/>
+          </a:solidFill>
+          <a:ln>
+            <a:noFill/>
+          </a:ln>
+          <a:effectLst/>
+        </p:spPr>
+        <p:style>
+          <a:lnRef idx="1">
+            <a:schemeClr val="accent1"/>
+          </a:lnRef>
+          <a:fillRef idx="3">
+            <a:schemeClr val="accent1"/>
+          </a:fillRef>
+          <a:effectRef idx="2">
+            <a:schemeClr val="accent1"/>
+          </a:effectRef>
+          <a:fontRef idx="minor">
+            <a:schemeClr val="lt1"/>
+          </a:fontRef>
+        </p:style>
+        <p:txBody>
+          <a:bodyPr rtlCol="0" anchor="ctr"/>
+          <a:lstStyle/>
+          <a:p>
+            <a:pPr algn="ctr"/>
+          </a:p>
+        </p:txBody>
+      </p:sp>
+      <p:sp>
+        <p:nvSpPr>
+          <p:cNvPr id="5" name="TextBox 4"/>
+          <p:cNvSpPr txBox="1"/>
+          <p:nvPr/>
+        </p:nvSpPr>
+        <p:spPr>
+          <a:xfrm>
+            <a:off x="502920" y="6455664"/>
+            <a:ext cx="7315200" cy="320040"/>
           </a:xfrm>
           <a:prstGeom prst="rect">
             <a:avLst/>
@@ -5357,27 +5569,27 @@
               </a:spcAft>
             </a:pPr>
             <a:r>
-              <a:rPr sz="1600" b="1">
-                <a:solidFill>
-                  <a:srgbClr val="FFFFFF"/>
-                </a:solidFill>
-                <a:latin typeface="Calibri"/>
-              </a:rPr>
-              <a:t>Mon avis</a:t>
-            </a:r>
-          </a:p>
-        </p:txBody>
-      </p:sp>
-      <p:sp>
-        <p:nvSpPr>
-          <p:cNvPr id="14" name="TextBox 13"/>
+              <a:rPr sz="1000" b="0">
+                <a:solidFill>
+                  <a:srgbClr val="979FB0"/>
+                </a:solidFill>
+                <a:latin typeface="Calibri"/>
+              </a:rPr>
+              <a:t>Argo Rollouts — Projet de recherche Kubernetes &amp; GitOps</a:t>
+            </a:r>
+          </a:p>
+        </p:txBody>
+      </p:sp>
+      <p:sp>
+        <p:nvSpPr>
+          <p:cNvPr id="6" name="TextBox 5"/>
           <p:cNvSpPr txBox="1"/>
           <p:nvPr/>
         </p:nvSpPr>
         <p:spPr>
           <a:xfrm>
-            <a:off x="6537959" y="2313432"/>
-            <a:ext cx="4617720" cy="1783080"/>
+            <a:off x="10058400" y="6455664"/>
+            <a:ext cx="1627632" cy="320040"/>
           </a:xfrm>
           <a:prstGeom prst="rect">
             <a:avLst/>
@@ -5385,106 +5597,41 @@
           <a:noFill/>
         </p:spPr>
         <p:txBody>
-          <a:bodyPr wrap="square" lIns="0" rIns="0" tIns="0" bIns="0">
+          <a:bodyPr wrap="square" anchor="t" lIns="0" rIns="0" tIns="0" bIns="0">
             <a:spAutoFit/>
           </a:bodyPr>
           <a:lstStyle/>
           <a:p>
-            <a:pPr>
-              <a:spcBef>
-                <a:spcPts val="0"/>
-              </a:spcBef>
-              <a:spcAft>
-                <a:spcPts val="600"/>
-              </a:spcAft>
-            </a:pPr>
-            <a:r>
-              <a:rPr sz="1400" b="1">
-                <a:solidFill>
-                  <a:srgbClr val="3FC46B"/>
-                </a:solidFill>
-                <a:latin typeface="Calibri"/>
-              </a:rPr>
-              <a:t>✓  </a:t>
-            </a:r>
-            <a:r>
-              <a:rPr sz="1400" b="1">
-                <a:solidFill>
-                  <a:srgbClr val="3FC46B"/>
-                </a:solidFill>
-                <a:latin typeface="Calibri"/>
-              </a:rPr>
-              <a:t>Excellent compromis sécurité / vélocité</a:t>
-            </a:r>
-          </a:p>
-          <a:p>
-            <a:pPr>
-              <a:spcBef>
-                <a:spcPts val="0"/>
-              </a:spcBef>
-              <a:spcAft>
-                <a:spcPts val="600"/>
-              </a:spcAft>
-            </a:pPr>
-            <a:r>
-              <a:rPr sz="1400" b="1">
-                <a:solidFill>
-                  <a:srgbClr val="979FB0"/>
-                </a:solidFill>
-                <a:latin typeface="Calibri"/>
-              </a:rPr>
-              <a:t>▸  </a:t>
-            </a:r>
-            <a:r>
-              <a:rPr sz="1400" b="0">
-                <a:solidFill>
-                  <a:srgbClr val="979FB0"/>
-                </a:solidFill>
-                <a:latin typeface="Calibri"/>
-              </a:rPr>
-              <a:t>Pour des services critiques à fort trafic</a:t>
-            </a:r>
-          </a:p>
-          <a:p>
-            <a:pPr>
-              <a:spcBef>
-                <a:spcPts val="0"/>
-              </a:spcBef>
-              <a:spcAft>
-                <a:spcPts val="600"/>
-              </a:spcAft>
-            </a:pPr>
-            <a:r>
-              <a:rPr sz="1400" b="1">
-                <a:solidFill>
-                  <a:srgbClr val="F0645A"/>
-                </a:solidFill>
-                <a:latin typeface="Calibri"/>
-              </a:rPr>
-              <a:t>✕  </a:t>
-            </a:r>
-            <a:r>
-              <a:rPr sz="1400" b="1">
-                <a:solidFill>
-                  <a:srgbClr val="F0645A"/>
-                </a:solidFill>
-                <a:latin typeface="Calibri"/>
-              </a:rPr>
-              <a:t>Overkill pour un petit mono-service</a:t>
-            </a:r>
-          </a:p>
-        </p:txBody>
-      </p:sp>
-      <p:sp>
-        <p:nvSpPr>
-          <p:cNvPr id="15" name="Rounded Rectangle 14"/>
+            <a:pPr algn="r">
+              <a:spcBef>
+                <a:spcPts val="0"/>
+              </a:spcBef>
+              <a:spcAft>
+                <a:spcPts val="400"/>
+              </a:spcAft>
+            </a:pPr>
+            <a:r>
+              <a:rPr sz="1000" b="1">
+                <a:solidFill>
+                  <a:srgbClr val="EF7627"/>
+                </a:solidFill>
+                <a:latin typeface="Calibri"/>
+              </a:rPr>
+              <a:t>12</a:t>
+            </a:r>
+          </a:p>
+        </p:txBody>
+      </p:sp>
+      <p:sp>
+        <p:nvSpPr>
+          <p:cNvPr id="7" name="Rounded Rectangle 6"/>
           <p:cNvSpPr/>
           <p:nvPr/>
         </p:nvSpPr>
         <p:spPr>
           <a:xfrm>
-            <a:off x="777240" y="4480560"/>
-            <a:ext cx="10607040" cy="1417320"/>
+            <a:off x="777240" y="1600200"/>
+            <a:ext cx="5257800" cy="2697480"/>
           </a:xfrm>
           <a:prstGeom prst="roundRect">
             <a:avLst>
@@ -5525,6 +5672,488 @@
       </p:sp>
       <p:sp>
         <p:nvSpPr>
+          <p:cNvPr id="8" name="Rectangle 7"/>
+          <p:cNvSpPr/>
+          <p:nvPr/>
+        </p:nvSpPr>
+        <p:spPr>
+          <a:xfrm>
+            <a:off x="777240" y="1764792"/>
+            <a:ext cx="91440" cy="384048"/>
+          </a:xfrm>
+          <a:prstGeom prst="rect">
+            <a:avLst/>
+          </a:prstGeom>
+          <a:solidFill>
+            <a:srgbClr val="55A8F5"/>
+          </a:solidFill>
+          <a:ln>
+            <a:noFill/>
+          </a:ln>
+          <a:effectLst/>
+        </p:spPr>
+        <p:style>
+          <a:lnRef idx="1">
+            <a:schemeClr val="accent1"/>
+          </a:lnRef>
+          <a:fillRef idx="3">
+            <a:schemeClr val="accent1"/>
+          </a:fillRef>
+          <a:effectRef idx="2">
+            <a:schemeClr val="accent1"/>
+          </a:effectRef>
+          <a:fontRef idx="minor">
+            <a:schemeClr val="lt1"/>
+          </a:fontRef>
+        </p:style>
+        <p:txBody>
+          <a:bodyPr rtlCol="0" anchor="ctr"/>
+          <a:lstStyle/>
+          <a:p>
+            <a:pPr algn="ctr"/>
+          </a:p>
+        </p:txBody>
+      </p:sp>
+      <p:sp>
+        <p:nvSpPr>
+          <p:cNvPr id="9" name="TextBox 8"/>
+          <p:cNvSpPr txBox="1"/>
+          <p:nvPr/>
+        </p:nvSpPr>
+        <p:spPr>
+          <a:xfrm>
+            <a:off x="1051560" y="1783080"/>
+            <a:ext cx="4800600" cy="411480"/>
+          </a:xfrm>
+          <a:prstGeom prst="rect">
+            <a:avLst/>
+          </a:prstGeom>
+          <a:noFill/>
+        </p:spPr>
+        <p:txBody>
+          <a:bodyPr wrap="square" anchor="t" lIns="0" rIns="0" tIns="0" bIns="0">
+            <a:spAutoFit/>
+          </a:bodyPr>
+          <a:lstStyle/>
+          <a:p>
+            <a:pPr algn="l">
+              <a:spcBef>
+                <a:spcPts val="0"/>
+              </a:spcBef>
+              <a:spcAft>
+                <a:spcPts val="400"/>
+              </a:spcAft>
+            </a:pPr>
+            <a:r>
+              <a:rPr sz="1600" b="1">
+                <a:solidFill>
+                  <a:srgbClr val="FFFFFF"/>
+                </a:solidFill>
+                <a:latin typeface="Calibri"/>
+              </a:rPr>
+              <a:t>Ce que j'ai appris</a:t>
+            </a:r>
+          </a:p>
+        </p:txBody>
+      </p:sp>
+      <p:sp>
+        <p:nvSpPr>
+          <p:cNvPr id="10" name="TextBox 9"/>
+          <p:cNvSpPr txBox="1"/>
+          <p:nvPr/>
+        </p:nvSpPr>
+        <p:spPr>
+          <a:xfrm>
+            <a:off x="1051560" y="2313432"/>
+            <a:ext cx="4754880" cy="1783080"/>
+          </a:xfrm>
+          <a:prstGeom prst="rect">
+            <a:avLst/>
+          </a:prstGeom>
+          <a:noFill/>
+        </p:spPr>
+        <p:txBody>
+          <a:bodyPr wrap="square" lIns="0" rIns="0" tIns="0" bIns="0">
+            <a:spAutoFit/>
+          </a:bodyPr>
+          <a:lstStyle/>
+          <a:p>
+            <a:pPr>
+              <a:spcBef>
+                <a:spcPts val="0"/>
+              </a:spcBef>
+              <a:spcAft>
+                <a:spcPts val="600"/>
+              </a:spcAft>
+            </a:pPr>
+            <a:r>
+              <a:rPr sz="1400" b="1">
+                <a:solidFill>
+                  <a:srgbClr val="EF7627"/>
+                </a:solidFill>
+                <a:latin typeface="Calibri"/>
+              </a:rPr>
+              <a:t>▸  </a:t>
+            </a:r>
+            <a:r>
+              <a:rPr sz="1400" b="0">
+                <a:solidFill>
+                  <a:srgbClr val="E8EAED"/>
+                </a:solidFill>
+                <a:latin typeface="Calibri"/>
+              </a:rPr>
+              <a:t>Le progressive delivery en pratique</a:t>
+            </a:r>
+          </a:p>
+          <a:p>
+            <a:pPr>
+              <a:spcBef>
+                <a:spcPts val="0"/>
+              </a:spcBef>
+              <a:spcAft>
+                <a:spcPts val="600"/>
+              </a:spcAft>
+            </a:pPr>
+            <a:r>
+              <a:rPr sz="1400" b="1">
+                <a:solidFill>
+                  <a:srgbClr val="EF7627"/>
+                </a:solidFill>
+                <a:latin typeface="Calibri"/>
+              </a:rPr>
+              <a:t>▸  </a:t>
+            </a:r>
+            <a:r>
+              <a:rPr sz="1400" b="0">
+                <a:solidFill>
+                  <a:srgbClr val="E8EAED"/>
+                </a:solidFill>
+                <a:latin typeface="Calibri"/>
+              </a:rPr>
+              <a:t>L'imbrication GitOps ↔ Rollouts</a:t>
+            </a:r>
+          </a:p>
+          <a:p>
+            <a:pPr>
+              <a:spcBef>
+                <a:spcPts val="0"/>
+              </a:spcBef>
+              <a:spcAft>
+                <a:spcPts val="600"/>
+              </a:spcAft>
+            </a:pPr>
+            <a:r>
+              <a:rPr sz="1400" b="1">
+                <a:solidFill>
+                  <a:srgbClr val="EF7627"/>
+                </a:solidFill>
+                <a:latin typeface="Calibri"/>
+              </a:rPr>
+              <a:t>▸  </a:t>
+            </a:r>
+            <a:r>
+              <a:rPr sz="1400" b="0">
+                <a:solidFill>
+                  <a:srgbClr val="E8EAED"/>
+                </a:solidFill>
+                <a:latin typeface="Calibri"/>
+              </a:rPr>
+              <a:t>Les métriques comme contrat de qualité</a:t>
+            </a:r>
+          </a:p>
+        </p:txBody>
+      </p:sp>
+      <p:sp>
+        <p:nvSpPr>
+          <p:cNvPr id="11" name="Rounded Rectangle 10"/>
+          <p:cNvSpPr/>
+          <p:nvPr/>
+        </p:nvSpPr>
+        <p:spPr>
+          <a:xfrm>
+            <a:off x="6263640" y="1600200"/>
+            <a:ext cx="5120640" cy="2697480"/>
+          </a:xfrm>
+          <a:prstGeom prst="roundRect">
+            <a:avLst>
+              <a:gd name="adj" fmla="val 6000"/>
+            </a:avLst>
+          </a:prstGeom>
+          <a:solidFill>
+            <a:srgbClr val="1E2533"/>
+          </a:solidFill>
+          <a:ln w="12700">
+            <a:solidFill>
+              <a:srgbClr val="323C4F"/>
+            </a:solidFill>
+          </a:ln>
+          <a:effectLst/>
+        </p:spPr>
+        <p:style>
+          <a:lnRef idx="1">
+            <a:schemeClr val="accent1"/>
+          </a:lnRef>
+          <a:fillRef idx="3">
+            <a:schemeClr val="accent1"/>
+          </a:fillRef>
+          <a:effectRef idx="2">
+            <a:schemeClr val="accent1"/>
+          </a:effectRef>
+          <a:fontRef idx="minor">
+            <a:schemeClr val="lt1"/>
+          </a:fontRef>
+        </p:style>
+        <p:txBody>
+          <a:bodyPr rtlCol="0" anchor="ctr"/>
+          <a:lstStyle/>
+          <a:p>
+            <a:pPr algn="ctr"/>
+          </a:p>
+        </p:txBody>
+      </p:sp>
+      <p:sp>
+        <p:nvSpPr>
+          <p:cNvPr id="12" name="Rectangle 11"/>
+          <p:cNvSpPr/>
+          <p:nvPr/>
+        </p:nvSpPr>
+        <p:spPr>
+          <a:xfrm>
+            <a:off x="6263640" y="1764792"/>
+            <a:ext cx="91440" cy="384048"/>
+          </a:xfrm>
+          <a:prstGeom prst="rect">
+            <a:avLst/>
+          </a:prstGeom>
+          <a:solidFill>
+            <a:srgbClr val="EF7627"/>
+          </a:solidFill>
+          <a:ln>
+            <a:noFill/>
+          </a:ln>
+          <a:effectLst/>
+        </p:spPr>
+        <p:style>
+          <a:lnRef idx="1">
+            <a:schemeClr val="accent1"/>
+          </a:lnRef>
+          <a:fillRef idx="3">
+            <a:schemeClr val="accent1"/>
+          </a:fillRef>
+          <a:effectRef idx="2">
+            <a:schemeClr val="accent1"/>
+          </a:effectRef>
+          <a:fontRef idx="minor">
+            <a:schemeClr val="lt1"/>
+          </a:fontRef>
+        </p:style>
+        <p:txBody>
+          <a:bodyPr rtlCol="0" anchor="ctr"/>
+          <a:lstStyle/>
+          <a:p>
+            <a:pPr algn="ctr"/>
+          </a:p>
+        </p:txBody>
+      </p:sp>
+      <p:sp>
+        <p:nvSpPr>
+          <p:cNvPr id="13" name="TextBox 12"/>
+          <p:cNvSpPr txBox="1"/>
+          <p:nvPr/>
+        </p:nvSpPr>
+        <p:spPr>
+          <a:xfrm>
+            <a:off x="6537959" y="1783080"/>
+            <a:ext cx="4663440" cy="411480"/>
+          </a:xfrm>
+          <a:prstGeom prst="rect">
+            <a:avLst/>
+          </a:prstGeom>
+          <a:noFill/>
+        </p:spPr>
+        <p:txBody>
+          <a:bodyPr wrap="square" anchor="t" lIns="0" rIns="0" tIns="0" bIns="0">
+            <a:spAutoFit/>
+          </a:bodyPr>
+          <a:lstStyle/>
+          <a:p>
+            <a:pPr algn="l">
+              <a:spcBef>
+                <a:spcPts val="0"/>
+              </a:spcBef>
+              <a:spcAft>
+                <a:spcPts val="400"/>
+              </a:spcAft>
+            </a:pPr>
+            <a:r>
+              <a:rPr sz="1600" b="1">
+                <a:solidFill>
+                  <a:srgbClr val="FFFFFF"/>
+                </a:solidFill>
+                <a:latin typeface="Calibri"/>
+              </a:rPr>
+              <a:t>Mon avis</a:t>
+            </a:r>
+          </a:p>
+        </p:txBody>
+      </p:sp>
+      <p:sp>
+        <p:nvSpPr>
+          <p:cNvPr id="14" name="TextBox 13"/>
+          <p:cNvSpPr txBox="1"/>
+          <p:nvPr/>
+        </p:nvSpPr>
+        <p:spPr>
+          <a:xfrm>
+            <a:off x="6537959" y="2313432"/>
+            <a:ext cx="4617720" cy="1783080"/>
+          </a:xfrm>
+          <a:prstGeom prst="rect">
+            <a:avLst/>
+          </a:prstGeom>
+          <a:noFill/>
+        </p:spPr>
+        <p:txBody>
+          <a:bodyPr wrap="square" lIns="0" rIns="0" tIns="0" bIns="0">
+            <a:spAutoFit/>
+          </a:bodyPr>
+          <a:lstStyle/>
+          <a:p>
+            <a:pPr>
+              <a:spcBef>
+                <a:spcPts val="0"/>
+              </a:spcBef>
+              <a:spcAft>
+                <a:spcPts val="600"/>
+              </a:spcAft>
+            </a:pPr>
+            <a:r>
+              <a:rPr sz="1400" b="1">
+                <a:solidFill>
+                  <a:srgbClr val="3FC46B"/>
+                </a:solidFill>
+                <a:latin typeface="Calibri"/>
+              </a:rPr>
+              <a:t>✓  </a:t>
+            </a:r>
+            <a:r>
+              <a:rPr sz="1400" b="1">
+                <a:solidFill>
+                  <a:srgbClr val="3FC46B"/>
+                </a:solidFill>
+                <a:latin typeface="Calibri"/>
+              </a:rPr>
+              <a:t>Excellent compromis sécurité / vélocité</a:t>
+            </a:r>
+          </a:p>
+          <a:p>
+            <a:pPr>
+              <a:spcBef>
+                <a:spcPts val="0"/>
+              </a:spcBef>
+              <a:spcAft>
+                <a:spcPts val="600"/>
+              </a:spcAft>
+            </a:pPr>
+            <a:r>
+              <a:rPr sz="1400" b="1">
+                <a:solidFill>
+                  <a:srgbClr val="979FB0"/>
+                </a:solidFill>
+                <a:latin typeface="Calibri"/>
+              </a:rPr>
+              <a:t>▸  </a:t>
+            </a:r>
+            <a:r>
+              <a:rPr sz="1400" b="0">
+                <a:solidFill>
+                  <a:srgbClr val="979FB0"/>
+                </a:solidFill>
+                <a:latin typeface="Calibri"/>
+              </a:rPr>
+              <a:t>Pour des services critiques à fort trafic</a:t>
+            </a:r>
+          </a:p>
+          <a:p>
+            <a:pPr>
+              <a:spcBef>
+                <a:spcPts val="0"/>
+              </a:spcBef>
+              <a:spcAft>
+                <a:spcPts val="600"/>
+              </a:spcAft>
+            </a:pPr>
+            <a:r>
+              <a:rPr sz="1400" b="1">
+                <a:solidFill>
+                  <a:srgbClr val="F0645A"/>
+                </a:solidFill>
+                <a:latin typeface="Calibri"/>
+              </a:rPr>
+              <a:t>✕  </a:t>
+            </a:r>
+            <a:r>
+              <a:rPr sz="1400" b="1">
+                <a:solidFill>
+                  <a:srgbClr val="F0645A"/>
+                </a:solidFill>
+                <a:latin typeface="Calibri"/>
+              </a:rPr>
+              <a:t>Overkill pour un petit mono-service</a:t>
+            </a:r>
+          </a:p>
+        </p:txBody>
+      </p:sp>
+      <p:sp>
+        <p:nvSpPr>
+          <p:cNvPr id="15" name="Rounded Rectangle 14"/>
+          <p:cNvSpPr/>
+          <p:nvPr/>
+        </p:nvSpPr>
+        <p:spPr>
+          <a:xfrm>
+            <a:off x="777240" y="4480560"/>
+            <a:ext cx="10607040" cy="1417320"/>
+          </a:xfrm>
+          <a:prstGeom prst="roundRect">
+            <a:avLst>
+              <a:gd name="adj" fmla="val 6000"/>
+            </a:avLst>
+          </a:prstGeom>
+          <a:solidFill>
+            <a:srgbClr val="1E2533"/>
+          </a:solidFill>
+          <a:ln w="12700">
+            <a:solidFill>
+              <a:srgbClr val="323C4F"/>
+            </a:solidFill>
+          </a:ln>
+          <a:effectLst/>
+        </p:spPr>
+        <p:style>
+          <a:lnRef idx="1">
+            <a:schemeClr val="accent1"/>
+          </a:lnRef>
+          <a:fillRef idx="3">
+            <a:schemeClr val="accent1"/>
+          </a:fillRef>
+          <a:effectRef idx="2">
+            <a:schemeClr val="accent1"/>
+          </a:effectRef>
+          <a:fontRef idx="minor">
+            <a:schemeClr val="lt1"/>
+          </a:fontRef>
+        </p:style>
+        <p:txBody>
+          <a:bodyPr rtlCol="0" anchor="ctr"/>
+          <a:lstStyle/>
+          <a:p>
+            <a:pPr algn="ctr"/>
+          </a:p>
+        </p:txBody>
+      </p:sp>
+      <p:sp>
+        <p:nvSpPr>
           <p:cNvPr id="16" name="Rectangle 15"/>
           <p:cNvSpPr/>
           <p:nvPr/>
@@ -5668,7 +6297,7 @@
 </p:sld>
 </file>
 
-<file path=ppt/slides/slide13.xml><?xml version="1.0" encoding="utf-8"?>
+<file path=ppt/slides/slide14.xml><?xml version="1.0" encoding="utf-8"?>
 <p:sld xmlns:a="http://schemas.openxmlformats.org/drawingml/2006/main" xmlns:p="http://schemas.openxmlformats.org/presentationml/2006/main" xmlns:r="http://schemas.openxmlformats.org/officeDocument/2006/relationships">
   <p:cSld>
     <p:bg>
@@ -12307,7 +12936,7 @@
         <p:spPr>
           <a:xfrm>
             <a:off x="6300216" y="3739896"/>
-            <a:ext cx="4810315" cy="2258568"/>
+            <a:ext cx="4496943" cy="2258568"/>
           </a:xfrm>
           <a:prstGeom prst="roundRect">
             <a:avLst>
@@ -12348,7 +12977,7 @@
       </p:sp>
       <p:pic>
         <p:nvPicPr>
-          <p:cNvPr id="15" name="Picture 14" descr="ui-app.png"/>
+          <p:cNvPr id="15" name="Picture 14" descr="ui-canary-grid.png"/>
           <p:cNvPicPr>
             <a:picLocks noChangeAspect="1"/>
           </p:cNvPicPr>
@@ -12363,7 +12992,7 @@
         <p:spPr>
           <a:xfrm>
             <a:off x="6355080" y="3794760"/>
-            <a:ext cx="4700587" cy="2148840"/>
+            <a:ext cx="4387215" cy="2148840"/>
           </a:xfrm>
           <a:prstGeom prst="rect">
             <a:avLst/>
@@ -12407,7 +13036,7 @@
                 </a:solidFill>
                 <a:latin typeface="Calibri"/>
               </a:rPr>
-              <a:t>Capture réelle de l'UI de l'app de démo</a:t>
+              <a:t>UI réelle : trafic réparti vert (canary) / bleu (stable)</a:t>
             </a:r>
           </a:p>
         </p:txBody>

</xml_diff>